<commit_message>
🤖 Weekly content brief — 2026-07-20
</commit_message>
<xml_diff>
--- a/automation/output/latest-carousel.pptx
+++ b/automation/output/latest-carousel.pptx
@@ -1282,7 +1282,7 @@
                 <a:ea typeface="Arial" pitchFamily="34" charset="-122"/>
                 <a:cs typeface="Arial" pitchFamily="34" charset="-120"/>
               </a:rPr>
-              <a:t>WEEK 29  ·  TOPIC 9/10</a:t>
+              <a:t>WEEK 30  ·  TOPIC 10/10</a:t>
             </a:r>
             <a:endParaRPr lang="en-US" sz="800" dirty="0"/>
           </a:p>
@@ -1321,7 +1321,7 @@
                 <a:ea typeface="Times New Roman" pitchFamily="34" charset="-122"/>
                 <a:cs typeface="Times New Roman" pitchFamily="34" charset="-120"/>
               </a:rPr>
-              <a:t>FOODS THAT REDUCE BELLY BLOATING</a:t>
+              <a:t>BREAKFAST FOODS RANKED BY PROTEIN</a:t>
             </a:r>
             <a:endParaRPr lang="en-US" sz="4400" dirty="0"/>
           </a:p>
@@ -1385,7 +1385,7 @@
                 <a:ea typeface="Times New Roman" pitchFamily="34" charset="-122"/>
                 <a:cs typeface="Times New Roman" pitchFamily="34" charset="-120"/>
               </a:rPr>
-              <a:t>"Bloating is usually food-related — and totally fixable."</a:t>
+              <a:t>"Your breakfast is either working for you or against you."</a:t>
             </a:r>
             <a:endParaRPr lang="en-US" sz="2400" dirty="0"/>
           </a:p>
@@ -1577,7 +1577,7 @@
                 <a:ea typeface="Times New Roman" pitchFamily="34" charset="-122"/>
                 <a:cs typeface="Times New Roman" pitchFamily="34" charset="-120"/>
               </a:rPr>
-              <a:t>ANTI-INFLAMMATORY FOODS</a:t>
+              <a:t>30G+ PROTEIN BREAKFASTS</a:t>
             </a:r>
             <a:endParaRPr lang="en-US" sz="3200" dirty="0"/>
           </a:p>
@@ -1641,7 +1641,7 @@
                 <a:ea typeface="Times New Roman" pitchFamily="34" charset="-122"/>
                 <a:cs typeface="Times New Roman" pitchFamily="34" charset="-120"/>
               </a:rPr>
-              <a:t>reduces gut irritation</a:t>
+              <a:t>sets the tone for the whole day</a:t>
             </a:r>
             <a:endParaRPr lang="en-US" sz="1500" dirty="0"/>
           </a:p>
@@ -1731,7 +1731,7 @@
                 <a:ea typeface="Times New Roman" pitchFamily="34" charset="-122"/>
                 <a:cs typeface="Times New Roman" pitchFamily="34" charset="-120"/>
               </a:rPr>
-              <a:t>Turmeric</a:t>
+              <a:t>4-Egg Omelette with Cheese</a:t>
             </a:r>
             <a:endParaRPr lang="en-US" sz="1700" dirty="0"/>
           </a:p>
@@ -1795,7 +1795,7 @@
                 <a:ea typeface="Times New Roman" pitchFamily="34" charset="-122"/>
                 <a:cs typeface="Times New Roman" pitchFamily="34" charset="-120"/>
               </a:rPr>
-              <a:t>29 kcal · 3g fiber</a:t>
+              <a:t>450 kcal · 34g protein</a:t>
             </a:r>
             <a:endParaRPr lang="en-US" sz="1300" dirty="0"/>
           </a:p>
@@ -1885,7 +1885,7 @@
                 <a:ea typeface="Times New Roman" pitchFamily="34" charset="-122"/>
                 <a:cs typeface="Times New Roman" pitchFamily="34" charset="-120"/>
               </a:rPr>
-              <a:t>Ginger</a:t>
+              <a:t>Greek Yogurt Parfait (300g)</a:t>
             </a:r>
             <a:endParaRPr lang="en-US" sz="1700" dirty="0"/>
           </a:p>
@@ -1949,7 +1949,7 @@
                 <a:ea typeface="Times New Roman" pitchFamily="34" charset="-122"/>
                 <a:cs typeface="Times New Roman" pitchFamily="34" charset="-120"/>
               </a:rPr>
-              <a:t>80 kcal · 2g fiber</a:t>
+              <a:t>380 kcal · 32g protein</a:t>
             </a:r>
             <a:endParaRPr lang="en-US" sz="1300" dirty="0"/>
           </a:p>
@@ -2039,7 +2039,7 @@
                 <a:ea typeface="Times New Roman" pitchFamily="34" charset="-122"/>
                 <a:cs typeface="Times New Roman" pitchFamily="34" charset="-120"/>
               </a:rPr>
-              <a:t>Pineapple</a:t>
+              <a:t>Protein Pancakes (3 stack)</a:t>
             </a:r>
             <a:endParaRPr lang="en-US" sz="1700" dirty="0"/>
           </a:p>
@@ -2103,7 +2103,7 @@
                 <a:ea typeface="Times New Roman" pitchFamily="34" charset="-122"/>
                 <a:cs typeface="Times New Roman" pitchFamily="34" charset="-120"/>
               </a:rPr>
-              <a:t>50 kcal · 1.4g fiber</a:t>
+              <a:t>420 kcal · 35g protein</a:t>
             </a:r>
             <a:endParaRPr lang="en-US" sz="1300" dirty="0"/>
           </a:p>
@@ -2193,7 +2193,7 @@
                 <a:ea typeface="Times New Roman" pitchFamily="34" charset="-122"/>
                 <a:cs typeface="Times New Roman" pitchFamily="34" charset="-120"/>
               </a:rPr>
-              <a:t>Salmon</a:t>
+              <a:t>Cottage Cheese Bowl with Nuts</a:t>
             </a:r>
             <a:endParaRPr lang="en-US" sz="1700" dirty="0"/>
           </a:p>
@@ -2257,7 +2257,7 @@
                 <a:ea typeface="Times New Roman" pitchFamily="34" charset="-122"/>
                 <a:cs typeface="Times New Roman" pitchFamily="34" charset="-120"/>
               </a:rPr>
-              <a:t>208 kcal · 2.6g omega-3</a:t>
+              <a:t>350 kcal · 31g protein</a:t>
             </a:r>
             <a:endParaRPr lang="en-US" sz="1300" dirty="0"/>
           </a:p>
@@ -2449,7 +2449,7 @@
                 <a:ea typeface="Times New Roman" pitchFamily="34" charset="-122"/>
                 <a:cs typeface="Times New Roman" pitchFamily="34" charset="-120"/>
               </a:rPr>
-              <a:t>PROBIOTIC FOODS</a:t>
+              <a:t>20–30G PROTEIN OPTIONS</a:t>
             </a:r>
             <a:endParaRPr lang="en-US" sz="3200" dirty="0"/>
           </a:p>
@@ -2513,7 +2513,7 @@
                 <a:ea typeface="Times New Roman" pitchFamily="34" charset="-122"/>
                 <a:cs typeface="Times New Roman" pitchFamily="34" charset="-120"/>
               </a:rPr>
-              <a:t>restores gut bacteria balance</a:t>
+              <a:t>solid start, easy to make</a:t>
             </a:r>
             <a:endParaRPr lang="en-US" sz="1500" dirty="0"/>
           </a:p>
@@ -2603,7 +2603,7 @@
                 <a:ea typeface="Times New Roman" pitchFamily="34" charset="-122"/>
                 <a:cs typeface="Times New Roman" pitchFamily="34" charset="-120"/>
               </a:rPr>
-              <a:t>Greek Yogurt</a:t>
+              <a:t>3 Scrambled Eggs on Toast</a:t>
             </a:r>
             <a:endParaRPr lang="en-US" sz="1700" dirty="0"/>
           </a:p>
@@ -2667,7 +2667,7 @@
                 <a:ea typeface="Times New Roman" pitchFamily="34" charset="-122"/>
                 <a:cs typeface="Times New Roman" pitchFamily="34" charset="-120"/>
               </a:rPr>
-              <a:t>59 kcal · 10g protein</a:t>
+              <a:t>370 kcal · 24g protein</a:t>
             </a:r>
             <a:endParaRPr lang="en-US" sz="1300" dirty="0"/>
           </a:p>
@@ -2757,7 +2757,7 @@
                 <a:ea typeface="Times New Roman" pitchFamily="34" charset="-122"/>
                 <a:cs typeface="Times New Roman" pitchFamily="34" charset="-120"/>
               </a:rPr>
-              <a:t>Kimchi</a:t>
+              <a:t>Overnight Oats with Protein</a:t>
             </a:r>
             <a:endParaRPr lang="en-US" sz="1700" dirty="0"/>
           </a:p>
@@ -2821,7 +2821,7 @@
                 <a:ea typeface="Times New Roman" pitchFamily="34" charset="-122"/>
                 <a:cs typeface="Times New Roman" pitchFamily="34" charset="-120"/>
               </a:rPr>
-              <a:t>15 kcal · 1.6g fiber</a:t>
+              <a:t>340 kcal · 25g protein</a:t>
             </a:r>
             <a:endParaRPr lang="en-US" sz="1300" dirty="0"/>
           </a:p>
@@ -2911,7 +2911,7 @@
                 <a:ea typeface="Times New Roman" pitchFamily="34" charset="-122"/>
                 <a:cs typeface="Times New Roman" pitchFamily="34" charset="-120"/>
               </a:rPr>
-              <a:t>Sauerkraut</a:t>
+              <a:t>Smoked Salmon Bagel</a:t>
             </a:r>
             <a:endParaRPr lang="en-US" sz="1700" dirty="0"/>
           </a:p>
@@ -2975,7 +2975,7 @@
                 <a:ea typeface="Times New Roman" pitchFamily="34" charset="-122"/>
                 <a:cs typeface="Times New Roman" pitchFamily="34" charset="-120"/>
               </a:rPr>
-              <a:t>19 kcal · 2.9g fiber</a:t>
+              <a:t>380 kcal · 22g protein</a:t>
             </a:r>
             <a:endParaRPr lang="en-US" sz="1300" dirty="0"/>
           </a:p>
@@ -3065,7 +3065,7 @@
                 <a:ea typeface="Times New Roman" pitchFamily="34" charset="-122"/>
                 <a:cs typeface="Times New Roman" pitchFamily="34" charset="-120"/>
               </a:rPr>
-              <a:t>Kefir</a:t>
+              <a:t>Turkey Sausage &amp; Egg Muffin</a:t>
             </a:r>
             <a:endParaRPr lang="en-US" sz="1700" dirty="0"/>
           </a:p>
@@ -3129,7 +3129,7 @@
                 <a:ea typeface="Times New Roman" pitchFamily="34" charset="-122"/>
                 <a:cs typeface="Times New Roman" pitchFamily="34" charset="-120"/>
               </a:rPr>
-              <a:t>63 kcal · 3.3g protein</a:t>
+              <a:t>350 kcal · 26g protein</a:t>
             </a:r>
             <a:endParaRPr lang="en-US" sz="1300" dirty="0"/>
           </a:p>
@@ -3321,7 +3321,7 @@
                 <a:ea typeface="Times New Roman" pitchFamily="34" charset="-122"/>
                 <a:cs typeface="Times New Roman" pitchFamily="34" charset="-120"/>
               </a:rPr>
-              <a:t>NATURAL DIURETICS</a:t>
+              <a:t>10–20G PROTEIN OPTIONS</a:t>
             </a:r>
             <a:endParaRPr lang="en-US" sz="3200" dirty="0"/>
           </a:p>
@@ -3385,7 +3385,7 @@
                 <a:ea typeface="Times New Roman" pitchFamily="34" charset="-122"/>
                 <a:cs typeface="Times New Roman" pitchFamily="34" charset="-120"/>
               </a:rPr>
-              <a:t>flushes excess water weight</a:t>
+              <a:t>better than most who skip it</a:t>
             </a:r>
             <a:endParaRPr lang="en-US" sz="1500" dirty="0"/>
           </a:p>
@@ -3475,7 +3475,7 @@
                 <a:ea typeface="Times New Roman" pitchFamily="34" charset="-122"/>
                 <a:cs typeface="Times New Roman" pitchFamily="34" charset="-120"/>
               </a:rPr>
-              <a:t>Cucumber</a:t>
+              <a:t>2 Boiled Eggs</a:t>
             </a:r>
             <a:endParaRPr lang="en-US" sz="1700" dirty="0"/>
           </a:p>
@@ -3539,7 +3539,7 @@
                 <a:ea typeface="Times New Roman" pitchFamily="34" charset="-122"/>
                 <a:cs typeface="Times New Roman" pitchFamily="34" charset="-120"/>
               </a:rPr>
-              <a:t>16 kcal · 95g water</a:t>
+              <a:t>155 kcal · 13g protein</a:t>
             </a:r>
             <a:endParaRPr lang="en-US" sz="1300" dirty="0"/>
           </a:p>
@@ -3629,7 +3629,7 @@
                 <a:ea typeface="Times New Roman" pitchFamily="34" charset="-122"/>
                 <a:cs typeface="Times New Roman" pitchFamily="34" charset="-120"/>
               </a:rPr>
-              <a:t>Watermelon</a:t>
+              <a:t>Peanut Butter Toast (2 slices)</a:t>
             </a:r>
             <a:endParaRPr lang="en-US" sz="1700" dirty="0"/>
           </a:p>
@@ -3693,7 +3693,7 @@
                 <a:ea typeface="Times New Roman" pitchFamily="34" charset="-122"/>
                 <a:cs typeface="Times New Roman" pitchFamily="34" charset="-120"/>
               </a:rPr>
-              <a:t>30 kcal · 92g water</a:t>
+              <a:t>320 kcal · 12g protein</a:t>
             </a:r>
             <a:endParaRPr lang="en-US" sz="1300" dirty="0"/>
           </a:p>
@@ -3783,7 +3783,7 @@
                 <a:ea typeface="Times New Roman" pitchFamily="34" charset="-122"/>
                 <a:cs typeface="Times New Roman" pitchFamily="34" charset="-120"/>
               </a:rPr>
-              <a:t>Celery</a:t>
+              <a:t>Regular Oatmeal with Milk</a:t>
             </a:r>
             <a:endParaRPr lang="en-US" sz="1700" dirty="0"/>
           </a:p>
@@ -3847,7 +3847,7 @@
                 <a:ea typeface="Times New Roman" pitchFamily="34" charset="-122"/>
                 <a:cs typeface="Times New Roman" pitchFamily="34" charset="-120"/>
               </a:rPr>
-              <a:t>14 kcal · 95g water</a:t>
+              <a:t>250 kcal · 11g protein</a:t>
             </a:r>
             <a:endParaRPr lang="en-US" sz="1300" dirty="0"/>
           </a:p>
@@ -3937,7 +3937,7 @@
                 <a:ea typeface="Times New Roman" pitchFamily="34" charset="-122"/>
                 <a:cs typeface="Times New Roman" pitchFamily="34" charset="-120"/>
               </a:rPr>
-              <a:t>Asparagus</a:t>
+              <a:t>Avocado Toast with 1 Egg</a:t>
             </a:r>
             <a:endParaRPr lang="en-US" sz="1700" dirty="0"/>
           </a:p>
@@ -4001,7 +4001,7 @@
                 <a:ea typeface="Times New Roman" pitchFamily="34" charset="-122"/>
                 <a:cs typeface="Times New Roman" pitchFamily="34" charset="-120"/>
               </a:rPr>
-              <a:t>20 kcal · 2.1g fiber</a:t>
+              <a:t>290 kcal · 10g protein</a:t>
             </a:r>
             <a:endParaRPr lang="en-US" sz="1300" dirty="0"/>
           </a:p>
@@ -4193,7 +4193,7 @@
                 <a:ea typeface="Times New Roman" pitchFamily="34" charset="-122"/>
                 <a:cs typeface="Times New Roman" pitchFamily="34" charset="-120"/>
               </a:rPr>
-              <a:t>DIGESTIVE AIDS</a:t>
+              <a:t>HIGH-SUGAR BREAKFASTS TO AVOID</a:t>
             </a:r>
             <a:endParaRPr lang="en-US" sz="3200" dirty="0"/>
           </a:p>
@@ -4257,7 +4257,7 @@
                 <a:ea typeface="Times New Roman" pitchFamily="34" charset="-122"/>
                 <a:cs typeface="Times New Roman" pitchFamily="34" charset="-120"/>
               </a:rPr>
-              <a:t>speeds up slow digestion</a:t>
+              <a:t>these spike blood sugar fast</a:t>
             </a:r>
             <a:endParaRPr lang="en-US" sz="1500" dirty="0"/>
           </a:p>
@@ -4347,7 +4347,7 @@
                 <a:ea typeface="Times New Roman" pitchFamily="34" charset="-122"/>
                 <a:cs typeface="Times New Roman" pitchFamily="34" charset="-120"/>
               </a:rPr>
-              <a:t>Papaya</a:t>
+              <a:t>Frosted Cereal with Milk</a:t>
             </a:r>
             <a:endParaRPr lang="en-US" sz="1700" dirty="0"/>
           </a:p>
@@ -4411,7 +4411,7 @@
                 <a:ea typeface="Times New Roman" pitchFamily="34" charset="-122"/>
                 <a:cs typeface="Times New Roman" pitchFamily="34" charset="-120"/>
               </a:rPr>
-              <a:t>43 kcal · 1.7g fiber</a:t>
+              <a:t>310 kcal · 4g protein</a:t>
             </a:r>
             <a:endParaRPr lang="en-US" sz="1300" dirty="0"/>
           </a:p>
@@ -4501,7 +4501,7 @@
                 <a:ea typeface="Times New Roman" pitchFamily="34" charset="-122"/>
                 <a:cs typeface="Times New Roman" pitchFamily="34" charset="-120"/>
               </a:rPr>
-              <a:t>Fennel</a:t>
+              <a:t>Chocolate Chip Muffin</a:t>
             </a:r>
             <a:endParaRPr lang="en-US" sz="1700" dirty="0"/>
           </a:p>
@@ -4565,7 +4565,7 @@
                 <a:ea typeface="Times New Roman" pitchFamily="34" charset="-122"/>
                 <a:cs typeface="Times New Roman" pitchFamily="34" charset="-120"/>
               </a:rPr>
-              <a:t>31 kcal · 3.1g fiber</a:t>
+              <a:t>450 kcal · 5g protein</a:t>
             </a:r>
             <a:endParaRPr lang="en-US" sz="1300" dirty="0"/>
           </a:p>
@@ -4655,7 +4655,7 @@
                 <a:ea typeface="Times New Roman" pitchFamily="34" charset="-122"/>
                 <a:cs typeface="Times New Roman" pitchFamily="34" charset="-120"/>
               </a:rPr>
-              <a:t>Banana</a:t>
+              <a:t>Syrup-Loaded Pancakes</a:t>
             </a:r>
             <a:endParaRPr lang="en-US" sz="1700" dirty="0"/>
           </a:p>
@@ -4719,7 +4719,7 @@
                 <a:ea typeface="Times New Roman" pitchFamily="34" charset="-122"/>
                 <a:cs typeface="Times New Roman" pitchFamily="34" charset="-120"/>
               </a:rPr>
-              <a:t>89 kcal · 2.6g fiber</a:t>
+              <a:t>520 kcal · 6g protein</a:t>
             </a:r>
             <a:endParaRPr lang="en-US" sz="1300" dirty="0"/>
           </a:p>
@@ -4809,7 +4809,7 @@
                 <a:ea typeface="Times New Roman" pitchFamily="34" charset="-122"/>
                 <a:cs typeface="Times New Roman" pitchFamily="34" charset="-120"/>
               </a:rPr>
-              <a:t>Peppermint Tea</a:t>
+              <a:t>Store-Bought Acai Bowl</a:t>
             </a:r>
             <a:endParaRPr lang="en-US" sz="1700" dirty="0"/>
           </a:p>
@@ -4873,7 +4873,7 @@
                 <a:ea typeface="Times New Roman" pitchFamily="34" charset="-122"/>
                 <a:cs typeface="Times New Roman" pitchFamily="34" charset="-120"/>
               </a:rPr>
-              <a:t>2 kcal · 0g sugar</a:t>
+              <a:t>490 kcal · 3g protein</a:t>
             </a:r>
             <a:endParaRPr lang="en-US" sz="1300" dirty="0"/>
           </a:p>

</xml_diff>